<commit_message>
docs: add keller poc runbook and skills
</commit_message>
<xml_diff>
--- a/outputs/keller-poc/AgentRun-Hackathon-Pitch.pptx
+++ b/outputs/keller-poc/AgentRun-Hackathon-Pitch.pptx
@@ -1426,7 +1426,7 @@
           <a:lstStyle/>
           <a:p>
             <a:r>
-              <a:t>这是最有力的 demo 时刻。Beth 说一句话，FIJI 真的打出电话。这是 RC 独一无二的能力。</a:t>
+              <a:t>重点：Bot 不打电话，但它把所有上下文和联系信息准备好，Beth 看完 Card 直接点发短信，Lowe's 收到短信会主动回电。这比 bot 自动拨号更符合企业工作流。</a:t>
             </a:r>
           </a:p>
         </p:txBody>
@@ -12348,7 +12348,7 @@
                   <a:srgbClr val="00D4BE"/>
                 </a:solidFill>
               </a:rPr>
-              <a:t>护城河：RC 的 SMS · Fax · Phone API  —  竞争对手没有</a:t>
+              <a:t>护城河：RC 的 SMS · Fax · Team Message API  —  竞争对手没有</a:t>
             </a:r>
           </a:p>
         </p:txBody>
@@ -15475,7 +15475,7 @@
         <p:spPr>
           <a:xfrm>
             <a:off x="2286000" y="228600"/>
-            <a:ext cx="9144000" cy="502920"/>
+            <a:ext cx="9601200" cy="502920"/>
           </a:xfrm>
           <a:prstGeom prst="rect">
             <a:avLst/>
@@ -15490,12 +15490,12 @@
           <a:p>
             <a:pPr algn="l"/>
             <a:r>
-              <a:rPr sz="3000" b="1" i="0">
+              <a:rPr sz="2600" b="1" i="0">
                 <a:solidFill>
                   <a:srgbClr val="FFFFFF"/>
                 </a:solidFill>
               </a:rPr>
-              <a:t>说"打过去"，FIJI 真的拨出电话</a:t>
+              <a:t>Bot 准备完整上下文，一步发短信安排回电</a:t>
             </a:r>
           </a:p>
         </p:txBody>
@@ -15508,8 +15508,8 @@
         </p:nvSpPr>
         <p:spPr>
           <a:xfrm>
-            <a:off x="457200" y="1005840"/>
-            <a:ext cx="11247120" cy="685800"/>
+            <a:off x="457200" y="960120"/>
+            <a:ext cx="11247120" cy="594360"/>
           </a:xfrm>
           <a:prstGeom prst="rect">
             <a:avLst/>
@@ -15551,7 +15551,75 @@
         </p:nvSpPr>
         <p:spPr>
           <a:xfrm>
-            <a:off x="640080" y="1115568"/>
+            <a:off x="640080" y="1051560"/>
+            <a:ext cx="1371600" cy="320040"/>
+          </a:xfrm>
+          <a:prstGeom prst="rect">
+            <a:avLst/>
+          </a:prstGeom>
+          <a:noFill/>
+        </p:spPr>
+        <p:txBody>
+          <a:bodyPr wrap="square">
+            <a:spAutoFit/>
+          </a:bodyPr>
+          <a:lstStyle/>
+          <a:p>
+            <a:pPr algn="l"/>
+            <a:r>
+              <a:rPr sz="1300" b="1" i="0">
+                <a:solidFill>
+                  <a:srgbClr val="FFC107"/>
+                </a:solidFill>
+              </a:rPr>
+              <a:t>Beth:</a:t>
+            </a:r>
+          </a:p>
+        </p:txBody>
+      </p:sp>
+      <p:sp>
+        <p:nvSpPr>
+          <p:cNvPr id="8" name="TextBox 7"/>
+          <p:cNvSpPr txBox="1"/>
+          <p:nvPr/>
+        </p:nvSpPr>
+        <p:spPr>
+          <a:xfrm>
+            <a:off x="2011680" y="1051560"/>
+            <a:ext cx="9144000" cy="320040"/>
+          </a:xfrm>
+          <a:prstGeom prst="rect">
+            <a:avLst/>
+          </a:prstGeom>
+          <a:noFill/>
+        </p:spPr>
+        <p:txBody>
+          <a:bodyPr wrap="square">
+            <a:spAutoFit/>
+          </a:bodyPr>
+          <a:lstStyle/>
+          <a:p>
+            <a:pPr algn="l"/>
+            <a:r>
+              <a:rPr sz="1400" b="0" i="0">
+                <a:solidFill>
+                  <a:srgbClr val="FFFFFF"/>
+                </a:solidFill>
+              </a:rPr>
+              <a:t>"Lowe's HQ 双路升级，帮我处理联络"</a:t>
+            </a:r>
+          </a:p>
+        </p:txBody>
+      </p:sp>
+      <p:sp>
+        <p:nvSpPr>
+          <p:cNvPr id="9" name="TextBox 8"/>
+          <p:cNvSpPr txBox="1"/>
+          <p:nvPr/>
+        </p:nvSpPr>
+        <p:spPr>
+          <a:xfrm>
+            <a:off x="5943600" y="1627632"/>
             <a:ext cx="1371600" cy="365760"/>
           </a:xfrm>
           <a:prstGeom prst="rect">
@@ -15565,77 +15633,9 @@
           </a:bodyPr>
           <a:lstStyle/>
           <a:p>
-            <a:pPr algn="l"/>
-            <a:r>
-              <a:rPr sz="1400" b="1" i="0">
-                <a:solidFill>
-                  <a:srgbClr val="FFC107"/>
-                </a:solidFill>
-              </a:rPr>
-              <a:t>Beth:</a:t>
-            </a:r>
-          </a:p>
-        </p:txBody>
-      </p:sp>
-      <p:sp>
-        <p:nvSpPr>
-          <p:cNvPr id="8" name="TextBox 7"/>
-          <p:cNvSpPr txBox="1"/>
-          <p:nvPr/>
-        </p:nvSpPr>
-        <p:spPr>
-          <a:xfrm>
-            <a:off x="2011680" y="1115568"/>
-            <a:ext cx="9144000" cy="365760"/>
-          </a:xfrm>
-          <a:prstGeom prst="rect">
-            <a:avLst/>
-          </a:prstGeom>
-          <a:noFill/>
-        </p:spPr>
-        <p:txBody>
-          <a:bodyPr wrap="square">
-            <a:spAutoFit/>
-          </a:bodyPr>
-          <a:lstStyle/>
-          <a:p>
-            <a:pPr algn="l"/>
-            <a:r>
-              <a:rPr sz="1600" b="0" i="0">
-                <a:solidFill>
-                  <a:srgbClr val="FFFFFF"/>
-                </a:solidFill>
-              </a:rPr>
-              <a:t>"Lowe's HQ 未接来电，打过去"</a:t>
-            </a:r>
-          </a:p>
-        </p:txBody>
-      </p:sp>
-      <p:sp>
-        <p:nvSpPr>
-          <p:cNvPr id="9" name="TextBox 8"/>
-          <p:cNvSpPr txBox="1"/>
-          <p:nvPr/>
-        </p:nvSpPr>
-        <p:spPr>
-          <a:xfrm>
-            <a:off x="5943600" y="1783080"/>
-            <a:ext cx="1371600" cy="457200"/>
-          </a:xfrm>
-          <a:prstGeom prst="rect">
-            <a:avLst/>
-          </a:prstGeom>
-          <a:noFill/>
-        </p:spPr>
-        <p:txBody>
-          <a:bodyPr wrap="square">
-            <a:spAutoFit/>
-          </a:bodyPr>
-          <a:lstStyle/>
-          <a:p>
             <a:pPr algn="ctr"/>
             <a:r>
-              <a:rPr sz="2400" b="0" i="0">
+              <a:rPr sz="2000" b="0" i="0">
                 <a:solidFill>
                   <a:srgbClr val="5A7A94"/>
                 </a:solidFill>
@@ -15653,8 +15653,391 @@
         </p:nvSpPr>
         <p:spPr>
           <a:xfrm>
-            <a:off x="457200" y="2331720"/>
-            <a:ext cx="2286000" cy="685800"/>
+            <a:off x="457200" y="2057400"/>
+            <a:ext cx="6400800" cy="3200400"/>
+          </a:xfrm>
+          <a:prstGeom prst="rect">
+            <a:avLst/>
+          </a:prstGeom>
+          <a:solidFill>
+            <a:srgbClr val="162A40"/>
+          </a:solidFill>
+          <a:ln>
+            <a:noFill/>
+          </a:ln>
+        </p:spPr>
+        <p:style>
+          <a:lnRef idx="1">
+            <a:schemeClr val="accent1"/>
+          </a:lnRef>
+          <a:fillRef idx="3">
+            <a:schemeClr val="accent1"/>
+          </a:fillRef>
+          <a:effectRef idx="2">
+            <a:schemeClr val="accent1"/>
+          </a:effectRef>
+          <a:fontRef idx="minor">
+            <a:schemeClr val="lt1"/>
+          </a:fontRef>
+        </p:style>
+        <p:txBody>
+          <a:bodyPr rtlCol="0" anchor="ctr"/>
+          <a:lstStyle/>
+          <a:p>
+            <a:pPr algn="ctr"/>
+          </a:p>
+        </p:txBody>
+      </p:sp>
+      <p:sp>
+        <p:nvSpPr>
+          <p:cNvPr id="11" name="TextBox 10"/>
+          <p:cNvSpPr txBox="1"/>
+          <p:nvPr/>
+        </p:nvSpPr>
+        <p:spPr>
+          <a:xfrm>
+            <a:off x="640080" y="2148840"/>
+            <a:ext cx="5943600" cy="384048"/>
+          </a:xfrm>
+          <a:prstGeom prst="rect">
+            <a:avLst/>
+          </a:prstGeom>
+          <a:noFill/>
+        </p:spPr>
+        <p:txBody>
+          <a:bodyPr wrap="square">
+            <a:spAutoFit/>
+          </a:bodyPr>
+          <a:lstStyle/>
+          <a:p>
+            <a:pPr algn="l"/>
+            <a:r>
+              <a:rPr sz="1200" b="0" i="0">
+                <a:solidFill>
+                  <a:srgbClr val="A8BBCC"/>
+                </a:solidFill>
+              </a:rPr>
+              <a:t>📋  Adaptive Card（RC 客户端内渲染）</a:t>
+            </a:r>
+          </a:p>
+        </p:txBody>
+      </p:sp>
+      <p:sp>
+        <p:nvSpPr>
+          <p:cNvPr id="12" name="TextBox 11"/>
+          <p:cNvSpPr txBox="1"/>
+          <p:nvPr/>
+        </p:nvSpPr>
+        <p:spPr>
+          <a:xfrm>
+            <a:off x="640080" y="2560320"/>
+            <a:ext cx="5943600" cy="457200"/>
+          </a:xfrm>
+          <a:prstGeom prst="rect">
+            <a:avLst/>
+          </a:prstGeom>
+          <a:noFill/>
+        </p:spPr>
+        <p:txBody>
+          <a:bodyPr wrap="square">
+            <a:spAutoFit/>
+          </a:bodyPr>
+          <a:lstStyle/>
+          <a:p>
+            <a:pPr algn="l"/>
+            <a:r>
+              <a:rPr sz="1600" b="1" i="0">
+                <a:solidFill>
+                  <a:srgbClr val="FFC107"/>
+                </a:solidFill>
+              </a:rPr>
+              <a:t>⚠️ 需要行动：A8810 双路升级</a:t>
+            </a:r>
+          </a:p>
+        </p:txBody>
+      </p:sp>
+      <p:sp>
+        <p:nvSpPr>
+          <p:cNvPr id="13" name="TextBox 12"/>
+          <p:cNvSpPr txBox="1"/>
+          <p:nvPr/>
+        </p:nvSpPr>
+        <p:spPr>
+          <a:xfrm>
+            <a:off x="640080" y="3063240"/>
+            <a:ext cx="2011680" cy="347472"/>
+          </a:xfrm>
+          <a:prstGeom prst="rect">
+            <a:avLst/>
+          </a:prstGeom>
+          <a:noFill/>
+        </p:spPr>
+        <p:txBody>
+          <a:bodyPr wrap="square">
+            <a:spAutoFit/>
+          </a:bodyPr>
+          <a:lstStyle/>
+          <a:p>
+            <a:pPr algn="l"/>
+            <a:r>
+              <a:rPr sz="1100" b="1" i="0">
+                <a:solidFill>
+                  <a:srgbClr val="A8BBCC"/>
+                </a:solidFill>
+              </a:rPr>
+              <a:t>Lowe's 质量标记:</a:t>
+            </a:r>
+          </a:p>
+        </p:txBody>
+      </p:sp>
+      <p:sp>
+        <p:nvSpPr>
+          <p:cNvPr id="14" name="TextBox 13"/>
+          <p:cNvSpPr txBox="1"/>
+          <p:nvPr/>
+        </p:nvSpPr>
+        <p:spPr>
+          <a:xfrm>
+            <a:off x="2697480" y="3063240"/>
+            <a:ext cx="3931920" cy="347472"/>
+          </a:xfrm>
+          <a:prstGeom prst="rect">
+            <a:avLst/>
+          </a:prstGeom>
+          <a:noFill/>
+        </p:spPr>
+        <p:txBody>
+          <a:bodyPr wrap="square">
+            <a:spAutoFit/>
+          </a:bodyPr>
+          <a:lstStyle/>
+          <a:p>
+            <a:pPr algn="l"/>
+            <a:r>
+              <a:rPr sz="1100" b="0" i="0">
+                <a:solidFill>
+                  <a:srgbClr val="FFFFFF"/>
+                </a:solidFill>
+              </a:rPr>
+              <a:t>REF-2026-0603-11 · SOP §7.3 · 截止 06/10</a:t>
+            </a:r>
+          </a:p>
+        </p:txBody>
+      </p:sp>
+      <p:sp>
+        <p:nvSpPr>
+          <p:cNvPr id="15" name="TextBox 14"/>
+          <p:cNvSpPr txBox="1"/>
+          <p:nvPr/>
+        </p:nvSpPr>
+        <p:spPr>
+          <a:xfrm>
+            <a:off x="640080" y="3474720"/>
+            <a:ext cx="2011680" cy="347472"/>
+          </a:xfrm>
+          <a:prstGeom prst="rect">
+            <a:avLst/>
+          </a:prstGeom>
+          <a:noFill/>
+        </p:spPr>
+        <p:txBody>
+          <a:bodyPr wrap="square">
+            <a:spAutoFit/>
+          </a:bodyPr>
+          <a:lstStyle/>
+          <a:p>
+            <a:pPr algn="l"/>
+            <a:r>
+              <a:rPr sz="1100" b="1" i="0">
+                <a:solidFill>
+                  <a:srgbClr val="A8BBCC"/>
+                </a:solidFill>
+              </a:rPr>
+              <a:t>客户投诉:</a:t>
+            </a:r>
+          </a:p>
+        </p:txBody>
+      </p:sp>
+      <p:sp>
+        <p:nvSpPr>
+          <p:cNvPr id="16" name="TextBox 15"/>
+          <p:cNvSpPr txBox="1"/>
+          <p:nvPr/>
+        </p:nvSpPr>
+        <p:spPr>
+          <a:xfrm>
+            <a:off x="2697480" y="3474720"/>
+            <a:ext cx="3931920" cy="347472"/>
+          </a:xfrm>
+          <a:prstGeom prst="rect">
+            <a:avLst/>
+          </a:prstGeom>
+          <a:noFill/>
+        </p:spPr>
+        <p:txBody>
+          <a:bodyPr wrap="square">
+            <a:spAutoFit/>
+          </a:bodyPr>
+          <a:lstStyle/>
+          <a:p>
+            <a:pPr algn="l"/>
+            <a:r>
+              <a:rPr sz="1100" b="0" i="0">
+                <a:solidFill>
+                  <a:srgbClr val="FFFFFF"/>
+                </a:solidFill>
+              </a:rPr>
+              <a:t>Jenkins no-show · sarah-bot 处理中</a:t>
+            </a:r>
+          </a:p>
+        </p:txBody>
+      </p:sp>
+      <p:sp>
+        <p:nvSpPr>
+          <p:cNvPr id="17" name="TextBox 16"/>
+          <p:cNvSpPr txBox="1"/>
+          <p:nvPr/>
+        </p:nvSpPr>
+        <p:spPr>
+          <a:xfrm>
+            <a:off x="640080" y="3886200"/>
+            <a:ext cx="2011680" cy="347472"/>
+          </a:xfrm>
+          <a:prstGeom prst="rect">
+            <a:avLst/>
+          </a:prstGeom>
+          <a:noFill/>
+        </p:spPr>
+        <p:txBody>
+          <a:bodyPr wrap="square">
+            <a:spAutoFit/>
+          </a:bodyPr>
+          <a:lstStyle/>
+          <a:p>
+            <a:pPr algn="l"/>
+            <a:r>
+              <a:rPr sz="1100" b="1" i="0">
+                <a:solidFill>
+                  <a:srgbClr val="A8BBCC"/>
+                </a:solidFill>
+              </a:rPr>
+              <a:t>推荐联系:</a:t>
+            </a:r>
+          </a:p>
+        </p:txBody>
+      </p:sp>
+      <p:sp>
+        <p:nvSpPr>
+          <p:cNvPr id="18" name="TextBox 17"/>
+          <p:cNvSpPr txBox="1"/>
+          <p:nvPr/>
+        </p:nvSpPr>
+        <p:spPr>
+          <a:xfrm>
+            <a:off x="2697480" y="3886200"/>
+            <a:ext cx="3931920" cy="347472"/>
+          </a:xfrm>
+          <a:prstGeom prst="rect">
+            <a:avLst/>
+          </a:prstGeom>
+          <a:noFill/>
+        </p:spPr>
+        <p:txBody>
+          <a:bodyPr wrap="square">
+            <a:spAutoFit/>
+          </a:bodyPr>
+          <a:lstStyle/>
+          <a:p>
+            <a:pPr algn="l"/>
+            <a:r>
+              <a:rPr sz="1100" b="0" i="0">
+                <a:solidFill>
+                  <a:srgbClr val="FFFFFF"/>
+                </a:solidFill>
+              </a:rPr>
+              <a:t>Lowe's Compliance  +1 919-555-0188</a:t>
+            </a:r>
+          </a:p>
+        </p:txBody>
+      </p:sp>
+      <p:sp>
+        <p:nvSpPr>
+          <p:cNvPr id="19" name="TextBox 18"/>
+          <p:cNvSpPr txBox="1"/>
+          <p:nvPr/>
+        </p:nvSpPr>
+        <p:spPr>
+          <a:xfrm>
+            <a:off x="640080" y="4297680"/>
+            <a:ext cx="2011680" cy="347472"/>
+          </a:xfrm>
+          <a:prstGeom prst="rect">
+            <a:avLst/>
+          </a:prstGeom>
+          <a:noFill/>
+        </p:spPr>
+        <p:txBody>
+          <a:bodyPr wrap="square">
+            <a:spAutoFit/>
+          </a:bodyPr>
+          <a:lstStyle/>
+          <a:p>
+            <a:pPr algn="l"/>
+            <a:r>
+              <a:rPr sz="1100" b="1" i="0">
+                <a:solidFill>
+                  <a:srgbClr val="A8BBCC"/>
+                </a:solidFill>
+              </a:rPr>
+              <a:t>建议话术:</a:t>
+            </a:r>
+          </a:p>
+        </p:txBody>
+      </p:sp>
+      <p:sp>
+        <p:nvSpPr>
+          <p:cNvPr id="20" name="TextBox 19"/>
+          <p:cNvSpPr txBox="1"/>
+          <p:nvPr/>
+        </p:nvSpPr>
+        <p:spPr>
+          <a:xfrm>
+            <a:off x="2697480" y="4297680"/>
+            <a:ext cx="3931920" cy="347472"/>
+          </a:xfrm>
+          <a:prstGeom prst="rect">
+            <a:avLst/>
+          </a:prstGeom>
+          <a:noFill/>
+        </p:spPr>
+        <p:txBody>
+          <a:bodyPr wrap="square">
+            <a:spAutoFit/>
+          </a:bodyPr>
+          <a:lstStyle/>
+          <a:p>
+            <a:pPr algn="l"/>
+            <a:r>
+              <a:rPr sz="1100" b="0" i="0">
+                <a:solidFill>
+                  <a:srgbClr val="FFFFFF"/>
+                </a:solidFill>
+              </a:rPr>
+              <a:t>"Aware of A8810, Tom handling. Extension to 06/12?"</a:t>
+            </a:r>
+          </a:p>
+        </p:txBody>
+      </p:sp>
+      <p:sp>
+        <p:nvSpPr>
+          <p:cNvPr id="21" name="Rectangle 20"/>
+          <p:cNvSpPr/>
+          <p:nvPr/>
+        </p:nvSpPr>
+        <p:spPr>
+          <a:xfrm>
+            <a:off x="640080" y="4846320"/>
+            <a:ext cx="2560320" cy="320040"/>
           </a:xfrm>
           <a:prstGeom prst="rect">
             <a:avLst/>
@@ -15690,14 +16073,14 @@
       </p:sp>
       <p:sp>
         <p:nvSpPr>
-          <p:cNvPr id="11" name="TextBox 10"/>
-          <p:cNvSpPr txBox="1"/>
-          <p:nvPr/>
-        </p:nvSpPr>
-        <p:spPr>
-          <a:xfrm>
-            <a:off x="548640" y="2496312"/>
-            <a:ext cx="2103120" cy="411480"/>
+          <p:cNvPr id="22" name="TextBox 21"/>
+          <p:cNvSpPr txBox="1"/>
+          <p:nvPr/>
+        </p:nvSpPr>
+        <p:spPr>
+          <a:xfrm>
+            <a:off x="685800" y="4892040"/>
+            <a:ext cx="2468880" cy="256032"/>
           </a:xfrm>
           <a:prstGeom prst="rect">
             <a:avLst/>
@@ -15712,26 +16095,103 @@
           <a:p>
             <a:pPr algn="ctr"/>
             <a:r>
-              <a:rPr sz="1200" b="1" i="0">
+              <a:rPr sz="1000" b="1" i="0">
                 <a:solidFill>
                   <a:srgbClr val="FFFFFF"/>
                 </a:solidFill>
               </a:rPr>
-              <a:t>beth-bot</a:t>
-            </a:r>
-          </a:p>
-        </p:txBody>
-      </p:sp>
-      <p:sp>
-        <p:nvSpPr>
-          <p:cNvPr id="12" name="TextBox 11"/>
-          <p:cNvSpPr txBox="1"/>
-          <p:nvPr/>
-        </p:nvSpPr>
-        <p:spPr>
-          <a:xfrm>
-            <a:off x="2926080" y="2496312"/>
-            <a:ext cx="8961120" cy="457200"/>
+              <a:t>发短信给 Lowe's 安排回电</a:t>
+            </a:r>
+          </a:p>
+        </p:txBody>
+      </p:sp>
+      <p:sp>
+        <p:nvSpPr>
+          <p:cNvPr id="23" name="Rectangle 22"/>
+          <p:cNvSpPr/>
+          <p:nvPr/>
+        </p:nvSpPr>
+        <p:spPr>
+          <a:xfrm>
+            <a:off x="3383280" y="4846320"/>
+            <a:ext cx="2377440" cy="320040"/>
+          </a:xfrm>
+          <a:prstGeom prst="rect">
+            <a:avLst/>
+          </a:prstGeom>
+          <a:solidFill>
+            <a:srgbClr val="0D1B2A"/>
+          </a:solidFill>
+          <a:ln>
+            <a:noFill/>
+          </a:ln>
+        </p:spPr>
+        <p:style>
+          <a:lnRef idx="1">
+            <a:schemeClr val="accent1"/>
+          </a:lnRef>
+          <a:fillRef idx="3">
+            <a:schemeClr val="accent1"/>
+          </a:fillRef>
+          <a:effectRef idx="2">
+            <a:schemeClr val="accent1"/>
+          </a:effectRef>
+          <a:fontRef idx="minor">
+            <a:schemeClr val="lt1"/>
+          </a:fontRef>
+        </p:style>
+        <p:txBody>
+          <a:bodyPr rtlCol="0" anchor="ctr"/>
+          <a:lstStyle/>
+          <a:p>
+            <a:pPr algn="ctr"/>
+          </a:p>
+        </p:txBody>
+      </p:sp>
+      <p:sp>
+        <p:nvSpPr>
+          <p:cNvPr id="24" name="TextBox 23"/>
+          <p:cNvSpPr txBox="1"/>
+          <p:nvPr/>
+        </p:nvSpPr>
+        <p:spPr>
+          <a:xfrm>
+            <a:off x="3429000" y="4892040"/>
+            <a:ext cx="2286000" cy="256032"/>
+          </a:xfrm>
+          <a:prstGeom prst="rect">
+            <a:avLst/>
+          </a:prstGeom>
+          <a:noFill/>
+        </p:spPr>
+        <p:txBody>
+          <a:bodyPr wrap="square">
+            <a:spAutoFit/>
+          </a:bodyPr>
+          <a:lstStyle/>
+          <a:p>
+            <a:pPr algn="ctr"/>
+            <a:r>
+              <a:rPr sz="1000" b="0" i="0">
+                <a:solidFill>
+                  <a:srgbClr val="A8BBCC"/>
+                </a:solidFill>
+              </a:rPr>
+              <a:t>通知 Karen 我会处理</a:t>
+            </a:r>
+          </a:p>
+        </p:txBody>
+      </p:sp>
+      <p:sp>
+        <p:nvSpPr>
+          <p:cNvPr id="25" name="TextBox 24"/>
+          <p:cNvSpPr txBox="1"/>
+          <p:nvPr/>
+        </p:nvSpPr>
+        <p:spPr>
+          <a:xfrm>
+            <a:off x="7315200" y="2057400"/>
+            <a:ext cx="4572000" cy="411480"/>
           </a:xfrm>
           <a:prstGeom prst="rect">
             <a:avLst/>
@@ -15748,24 +16208,24 @@
             <a:r>
               <a:rPr sz="1300" b="0" i="0">
                 <a:solidFill>
-                  <a:srgbClr val="FFFFFF"/>
-                </a:solidFill>
-              </a:rPr>
-              <a:t>ACTION:PHONE_CALL to=+19195550188</a:t>
-            </a:r>
-          </a:p>
-        </p:txBody>
-      </p:sp>
-      <p:sp>
-        <p:nvSpPr>
-          <p:cNvPr id="13" name="TextBox 12"/>
-          <p:cNvSpPr txBox="1"/>
-          <p:nvPr/>
-        </p:nvSpPr>
-        <p:spPr>
-          <a:xfrm>
-            <a:off x="1371600" y="3035808"/>
-            <a:ext cx="914400" cy="274320"/>
+                  <a:srgbClr val="A8BBCC"/>
+                </a:solidFill>
+              </a:rPr>
+              <a:t>Beth 点击「发短信给 Lowe's」</a:t>
+            </a:r>
+          </a:p>
+        </p:txBody>
+      </p:sp>
+      <p:sp>
+        <p:nvSpPr>
+          <p:cNvPr id="26" name="TextBox 25"/>
+          <p:cNvSpPr txBox="1"/>
+          <p:nvPr/>
+        </p:nvSpPr>
+        <p:spPr>
+          <a:xfrm>
+            <a:off x="9144000" y="2514600"/>
+            <a:ext cx="1371600" cy="365760"/>
           </a:xfrm>
           <a:prstGeom prst="rect">
             <a:avLst/>
@@ -15780,7 +16240,7 @@
           <a:p>
             <a:pPr algn="ctr"/>
             <a:r>
-              <a:rPr sz="1400" b="0" i="0">
+              <a:rPr sz="1800" b="0" i="0">
                 <a:solidFill>
                   <a:srgbClr val="5A7A94"/>
                 </a:solidFill>
@@ -15792,14 +16252,14 @@
       </p:sp>
       <p:sp>
         <p:nvSpPr>
-          <p:cNvPr id="14" name="Rectangle 13"/>
+          <p:cNvPr id="27" name="Rectangle 26"/>
           <p:cNvSpPr/>
           <p:nvPr/>
         </p:nvSpPr>
         <p:spPr>
           <a:xfrm>
-            <a:off x="457200" y="3154679"/>
-            <a:ext cx="2286000" cy="685800"/>
+            <a:off x="7132320" y="2926080"/>
+            <a:ext cx="4572000" cy="2011680"/>
           </a:xfrm>
           <a:prstGeom prst="rect">
             <a:avLst/>
@@ -15835,48 +16295,86 @@
       </p:sp>
       <p:sp>
         <p:nvSpPr>
-          <p:cNvPr id="15" name="TextBox 14"/>
-          <p:cNvSpPr txBox="1"/>
-          <p:nvPr/>
-        </p:nvSpPr>
-        <p:spPr>
-          <a:xfrm>
-            <a:off x="548640" y="3319272"/>
-            <a:ext cx="2103120" cy="411480"/>
-          </a:xfrm>
-          <a:prstGeom prst="rect">
-            <a:avLst/>
-          </a:prstGeom>
-          <a:noFill/>
-        </p:spPr>
-        <p:txBody>
-          <a:bodyPr wrap="square">
-            <a:spAutoFit/>
-          </a:bodyPr>
-          <a:lstStyle/>
-          <a:p>
-            <a:pPr algn="ctr"/>
-            <a:r>
-              <a:rPr sz="1200" b="1" i="0">
+          <p:cNvPr id="28" name="TextBox 27"/>
+          <p:cNvSpPr txBox="1"/>
+          <p:nvPr/>
+        </p:nvSpPr>
+        <p:spPr>
+          <a:xfrm>
+            <a:off x="7315200" y="3017520"/>
+            <a:ext cx="4206240" cy="347472"/>
+          </a:xfrm>
+          <a:prstGeom prst="rect">
+            <a:avLst/>
+          </a:prstGeom>
+          <a:noFill/>
+        </p:spPr>
+        <p:txBody>
+          <a:bodyPr wrap="square">
+            <a:spAutoFit/>
+          </a:bodyPr>
+          <a:lstStyle/>
+          <a:p>
+            <a:pPr algn="l"/>
+            <a:r>
+              <a:rPr sz="1100" b="0" i="0">
+                <a:solidFill>
+                  <a:srgbClr val="A8BBCC"/>
+                </a:solidFill>
+              </a:rPr>
+              <a:t>📱 Lowe's HQ 收到 SMS：</a:t>
+            </a:r>
+          </a:p>
+        </p:txBody>
+      </p:sp>
+      <p:sp>
+        <p:nvSpPr>
+          <p:cNvPr id="29" name="TextBox 28"/>
+          <p:cNvSpPr txBox="1"/>
+          <p:nvPr/>
+        </p:nvSpPr>
+        <p:spPr>
+          <a:xfrm>
+            <a:off x="7315200" y="3401568"/>
+            <a:ext cx="4206240" cy="1463040"/>
+          </a:xfrm>
+          <a:prstGeom prst="rect">
+            <a:avLst/>
+          </a:prstGeom>
+          <a:noFill/>
+        </p:spPr>
+        <p:txBody>
+          <a:bodyPr wrap="square">
+            <a:spAutoFit/>
+          </a:bodyPr>
+          <a:lstStyle/>
+          <a:p>
+            <a:pPr algn="l"/>
+            <a:r>
+              <a:rPr sz="1200" b="0" i="1">
                 <a:solidFill>
                   <a:srgbClr val="FFFFFF"/>
                 </a:solidFill>
               </a:rPr>
-              <a:t>Control Plane</a:t>
-            </a:r>
-          </a:p>
-        </p:txBody>
-      </p:sp>
-      <p:sp>
-        <p:nvSpPr>
-          <p:cNvPr id="16" name="TextBox 15"/>
-          <p:cNvSpPr txBox="1"/>
-          <p:nvPr/>
-        </p:nvSpPr>
-        <p:spPr>
-          <a:xfrm>
-            <a:off x="2926080" y="3319272"/>
-            <a:ext cx="8961120" cy="457200"/>
+              <a:t>"Hi, Beth Owens from Keller.
+Following up on A8810 (REF-2026-0603-11).
+Can we schedule a call today?
+Available 2-5pm ET.
+Direct: +1 404-555-0001."</a:t>
+            </a:r>
+          </a:p>
+        </p:txBody>
+      </p:sp>
+      <p:sp>
+        <p:nvSpPr>
+          <p:cNvPr id="30" name="TextBox 29"/>
+          <p:cNvSpPr txBox="1"/>
+          <p:nvPr/>
+        </p:nvSpPr>
+        <p:spPr>
+          <a:xfrm>
+            <a:off x="7315200" y="4983480"/>
+            <a:ext cx="2743200" cy="320040"/>
           </a:xfrm>
           <a:prstGeom prst="rect">
             <a:avLst/>
@@ -15891,60 +16389,26 @@
           <a:p>
             <a:pPr algn="l"/>
             <a:r>
-              <a:rPr sz="1300" b="0" i="0">
-                <a:solidFill>
-                  <a:srgbClr val="FFFFFF"/>
-                </a:solidFill>
-              </a:rPr>
-              <a:t>记录 action_event：{type: PHONE_CALL, status: client_action_required, details: {make_call}}</a:t>
-            </a:r>
-          </a:p>
-        </p:txBody>
-      </p:sp>
-      <p:sp>
-        <p:nvSpPr>
-          <p:cNvPr id="17" name="TextBox 16"/>
-          <p:cNvSpPr txBox="1"/>
-          <p:nvPr/>
-        </p:nvSpPr>
-        <p:spPr>
-          <a:xfrm>
-            <a:off x="1371600" y="3858768"/>
-            <a:ext cx="914400" cy="274320"/>
-          </a:xfrm>
-          <a:prstGeom prst="rect">
-            <a:avLst/>
-          </a:prstGeom>
-          <a:noFill/>
-        </p:spPr>
-        <p:txBody>
-          <a:bodyPr wrap="square">
-            <a:spAutoFit/>
-          </a:bodyPr>
-          <a:lstStyle/>
-          <a:p>
-            <a:pPr algn="ctr"/>
-            <a:r>
-              <a:rPr sz="1400" b="0" i="0">
-                <a:solidFill>
-                  <a:srgbClr val="5A7A94"/>
-                </a:solidFill>
-              </a:rPr>
-              <a:t>↓</a:t>
-            </a:r>
-          </a:p>
-        </p:txBody>
-      </p:sp>
-      <p:sp>
-        <p:nvSpPr>
-          <p:cNvPr id="18" name="Rectangle 17"/>
+              <a:rPr sz="1300" b="1" i="0">
+                <a:solidFill>
+                  <a:srgbClr val="00C86E"/>
+                </a:solidFill>
+              </a:rPr>
+              <a:t>✅ SMS delivered</a:t>
+            </a:r>
+          </a:p>
+        </p:txBody>
+      </p:sp>
+      <p:sp>
+        <p:nvSpPr>
+          <p:cNvPr id="31" name="Rectangle 30"/>
           <p:cNvSpPr/>
           <p:nvPr/>
         </p:nvSpPr>
         <p:spPr>
           <a:xfrm>
-            <a:off x="457200" y="3977639"/>
-            <a:ext cx="2286000" cy="685800"/>
+            <a:off x="603504" y="5715000"/>
+            <a:ext cx="10972800" cy="25400"/>
           </a:xfrm>
           <a:prstGeom prst="rect">
             <a:avLst/>
@@ -15980,14 +16444,14 @@
       </p:sp>
       <p:sp>
         <p:nvSpPr>
-          <p:cNvPr id="19" name="TextBox 18"/>
-          <p:cNvSpPr txBox="1"/>
-          <p:nvPr/>
-        </p:nvSpPr>
-        <p:spPr>
-          <a:xfrm>
-            <a:off x="548640" y="4142231"/>
-            <a:ext cx="2103120" cy="411480"/>
+          <p:cNvPr id="32" name="TextBox 31"/>
+          <p:cNvSpPr txBox="1"/>
+          <p:nvPr/>
+        </p:nvSpPr>
+        <p:spPr>
+          <a:xfrm>
+            <a:off x="457200" y="5833872"/>
+            <a:ext cx="11247120" cy="384048"/>
           </a:xfrm>
           <a:prstGeom prst="rect">
             <a:avLst/>
@@ -16002,60 +16466,26 @@
           <a:p>
             <a:pPr algn="ctr"/>
             <a:r>
-              <a:rPr sz="1200" b="1" i="0">
-                <a:solidFill>
-                  <a:srgbClr val="FFFFFF"/>
-                </a:solidFill>
-              </a:rPr>
-              <a:t>FIJI AvaClientActionBridge</a:t>
-            </a:r>
-          </a:p>
-        </p:txBody>
-      </p:sp>
-      <p:sp>
-        <p:nvSpPr>
-          <p:cNvPr id="20" name="TextBox 19"/>
-          <p:cNvSpPr txBox="1"/>
-          <p:nvPr/>
-        </p:nvSpPr>
-        <p:spPr>
-          <a:xfrm>
-            <a:off x="2926080" y="4142231"/>
-            <a:ext cx="8961120" cy="457200"/>
-          </a:xfrm>
-          <a:prstGeom prst="rect">
-            <a:avLst/>
-          </a:prstGeom>
-          <a:noFill/>
-        </p:spPr>
-        <p:txBody>
-          <a:bodyPr wrap="square">
-            <a:spAutoFit/>
-          </a:bodyPr>
-          <a:lstStyle/>
-          <a:p>
-            <a:pPr algn="l"/>
-            <a:r>
-              <a:rPr sz="1300" b="0" i="0">
-                <a:solidFill>
-                  <a:srgbClr val="FFFFFF"/>
-                </a:solidFill>
-              </a:rPr>
-              <a:t>轮询到 event  →  executeAvaClientAction()</a:t>
-            </a:r>
-          </a:p>
-        </p:txBody>
-      </p:sp>
-      <p:sp>
-        <p:nvSpPr>
-          <p:cNvPr id="21" name="TextBox 20"/>
-          <p:cNvSpPr txBox="1"/>
-          <p:nvPr/>
-        </p:nvSpPr>
-        <p:spPr>
-          <a:xfrm>
-            <a:off x="1371600" y="4681727"/>
-            <a:ext cx="914400" cy="274320"/>
+              <a:rPr sz="1200" b="0" i="0">
+                <a:solidFill>
+                  <a:srgbClr val="5A7A94"/>
+                </a:solidFill>
+              </a:rPr>
+              <a:t>为什么比直接打更好：SMS 是异步的  ·  对方有准备  ·  Beth 有充分上下文再打  ·  任意 RC 客户端可用</a:t>
+            </a:r>
+          </a:p>
+        </p:txBody>
+      </p:sp>
+      <p:sp>
+        <p:nvSpPr>
+          <p:cNvPr id="33" name="TextBox 32"/>
+          <p:cNvSpPr txBox="1"/>
+          <p:nvPr/>
+        </p:nvSpPr>
+        <p:spPr>
+          <a:xfrm>
+            <a:off x="457200" y="6291072"/>
+            <a:ext cx="11247120" cy="384048"/>
           </a:xfrm>
           <a:prstGeom prst="rect">
             <a:avLst/>
@@ -16070,404 +16500,12 @@
           <a:p>
             <a:pPr algn="ctr"/>
             <a:r>
-              <a:rPr sz="1400" b="0" i="0">
-                <a:solidFill>
-                  <a:srgbClr val="5A7A94"/>
-                </a:solidFill>
-              </a:rPr>
-              <a:t>↓</a:t>
-            </a:r>
-          </a:p>
-        </p:txBody>
-      </p:sp>
-      <p:sp>
-        <p:nvSpPr>
-          <p:cNvPr id="22" name="Rectangle 21"/>
-          <p:cNvSpPr/>
-          <p:nvPr/>
-        </p:nvSpPr>
-        <p:spPr>
-          <a:xfrm>
-            <a:off x="457200" y="4800600"/>
-            <a:ext cx="2286000" cy="685800"/>
-          </a:xfrm>
-          <a:prstGeom prst="rect">
-            <a:avLst/>
-          </a:prstGeom>
-          <a:solidFill>
-            <a:srgbClr val="00C86E"/>
-          </a:solidFill>
-          <a:ln>
-            <a:noFill/>
-          </a:ln>
-        </p:spPr>
-        <p:style>
-          <a:lnRef idx="1">
-            <a:schemeClr val="accent1"/>
-          </a:lnRef>
-          <a:fillRef idx="3">
-            <a:schemeClr val="accent1"/>
-          </a:fillRef>
-          <a:effectRef idx="2">
-            <a:schemeClr val="accent1"/>
-          </a:effectRef>
-          <a:fontRef idx="minor">
-            <a:schemeClr val="lt1"/>
-          </a:fontRef>
-        </p:style>
-        <p:txBody>
-          <a:bodyPr rtlCol="0" anchor="ctr"/>
-          <a:lstStyle/>
-          <a:p>
-            <a:pPr algn="ctr"/>
-          </a:p>
-        </p:txBody>
-      </p:sp>
-      <p:sp>
-        <p:nvSpPr>
-          <p:cNvPr id="23" name="TextBox 22"/>
-          <p:cNvSpPr txBox="1"/>
-          <p:nvPr/>
-        </p:nvSpPr>
-        <p:spPr>
-          <a:xfrm>
-            <a:off x="548640" y="4965192"/>
-            <a:ext cx="2103120" cy="411480"/>
-          </a:xfrm>
-          <a:prstGeom prst="rect">
-            <a:avLst/>
-          </a:prstGeom>
-          <a:noFill/>
-        </p:spPr>
-        <p:txBody>
-          <a:bodyPr wrap="square">
-            <a:spAutoFit/>
-          </a:bodyPr>
-          <a:lstStyle/>
-          <a:p>
-            <a:pPr algn="ctr"/>
-            <a:r>
-              <a:rPr sz="1200" b="1" i="0">
-                <a:solidFill>
-                  <a:srgbClr val="FFFFFF"/>
-                </a:solidFill>
-              </a:rPr>
-              <a:t>FIJI directCall</a:t>
-            </a:r>
-          </a:p>
-        </p:txBody>
-      </p:sp>
-      <p:sp>
-        <p:nvSpPr>
-          <p:cNvPr id="24" name="TextBox 23"/>
-          <p:cNvSpPr txBox="1"/>
-          <p:nvPr/>
-        </p:nvSpPr>
-        <p:spPr>
-          <a:xfrm>
-            <a:off x="2926080" y="4965192"/>
-            <a:ext cx="8961120" cy="457200"/>
-          </a:xfrm>
-          <a:prstGeom prst="rect">
-            <a:avLst/>
-          </a:prstGeom>
-          <a:noFill/>
-        </p:spPr>
-        <p:txBody>
-          <a:bodyPr wrap="square">
-            <a:spAutoFit/>
-          </a:bodyPr>
-          <a:lstStyle/>
-          <a:p>
-            <a:pPr algn="l"/>
-            <a:r>
-              <a:rPr sz="1300" b="0" i="0">
-                <a:solidFill>
-                  <a:srgbClr val="FFFFFF"/>
-                </a:solidFill>
-              </a:rPr>
-              <a:t>以 Beth 当前登录身份拨出  ✅</a:t>
-            </a:r>
-          </a:p>
-        </p:txBody>
-      </p:sp>
-      <p:sp>
-        <p:nvSpPr>
-          <p:cNvPr id="25" name="Rectangle 24"/>
-          <p:cNvSpPr/>
-          <p:nvPr/>
-        </p:nvSpPr>
-        <p:spPr>
-          <a:xfrm>
-            <a:off x="603504" y="5806440"/>
-            <a:ext cx="10972800" cy="25400"/>
-          </a:xfrm>
-          <a:prstGeom prst="rect">
-            <a:avLst/>
-          </a:prstGeom>
-          <a:solidFill>
-            <a:srgbClr val="00D4BE"/>
-          </a:solidFill>
-          <a:ln>
-            <a:noFill/>
-          </a:ln>
-        </p:spPr>
-        <p:style>
-          <a:lnRef idx="1">
-            <a:schemeClr val="accent1"/>
-          </a:lnRef>
-          <a:fillRef idx="3">
-            <a:schemeClr val="accent1"/>
-          </a:fillRef>
-          <a:effectRef idx="2">
-            <a:schemeClr val="accent1"/>
-          </a:effectRef>
-          <a:fontRef idx="minor">
-            <a:schemeClr val="lt1"/>
-          </a:fontRef>
-        </p:style>
-        <p:txBody>
-          <a:bodyPr rtlCol="0" anchor="ctr"/>
-          <a:lstStyle/>
-          <a:p>
-            <a:pPr algn="ctr"/>
-          </a:p>
-        </p:txBody>
-      </p:sp>
-      <p:sp>
-        <p:nvSpPr>
-          <p:cNvPr id="26" name="TextBox 25"/>
-          <p:cNvSpPr txBox="1"/>
-          <p:nvPr/>
-        </p:nvSpPr>
-        <p:spPr>
-          <a:xfrm>
-            <a:off x="1371600" y="5943600"/>
-            <a:ext cx="2743200" cy="411480"/>
-          </a:xfrm>
-          <a:prstGeom prst="rect">
-            <a:avLst/>
-          </a:prstGeom>
-          <a:noFill/>
-        </p:spPr>
-        <p:txBody>
-          <a:bodyPr wrap="square">
-            <a:spAutoFit/>
-          </a:bodyPr>
-          <a:lstStyle/>
-          <a:p>
-            <a:pPr algn="ctr"/>
-            <a:r>
-              <a:rPr sz="1600" b="0" i="0">
-                <a:solidFill>
-                  <a:srgbClr val="A8BBCC"/>
-                </a:solidFill>
-              </a:rPr>
-              <a:t>Copilot</a:t>
-            </a:r>
-          </a:p>
-        </p:txBody>
-      </p:sp>
-      <p:sp>
-        <p:nvSpPr>
-          <p:cNvPr id="27" name="TextBox 26"/>
-          <p:cNvSpPr txBox="1"/>
-          <p:nvPr/>
-        </p:nvSpPr>
-        <p:spPr>
-          <a:xfrm>
-            <a:off x="1371600" y="6327648"/>
-            <a:ext cx="2743200" cy="365760"/>
-          </a:xfrm>
-          <a:prstGeom prst="rect">
-            <a:avLst/>
-          </a:prstGeom>
-          <a:noFill/>
-        </p:spPr>
-        <p:txBody>
-          <a:bodyPr wrap="square">
-            <a:spAutoFit/>
-          </a:bodyPr>
-          <a:lstStyle/>
-          <a:p>
-            <a:pPr algn="ctr"/>
-            <a:r>
-              <a:rPr sz="2000" b="1" i="0">
-                <a:solidFill>
-                  <a:srgbClr val="FF4D4D"/>
-                </a:solidFill>
-              </a:rPr>
-              <a:t>✗</a:t>
-            </a:r>
-          </a:p>
-        </p:txBody>
-      </p:sp>
-      <p:sp>
-        <p:nvSpPr>
-          <p:cNvPr id="28" name="TextBox 27"/>
-          <p:cNvSpPr txBox="1"/>
-          <p:nvPr/>
-        </p:nvSpPr>
-        <p:spPr>
-          <a:xfrm>
-            <a:off x="4846320" y="5943600"/>
-            <a:ext cx="2743200" cy="411480"/>
-          </a:xfrm>
-          <a:prstGeom prst="rect">
-            <a:avLst/>
-          </a:prstGeom>
-          <a:noFill/>
-        </p:spPr>
-        <p:txBody>
-          <a:bodyPr wrap="square">
-            <a:spAutoFit/>
-          </a:bodyPr>
-          <a:lstStyle/>
-          <a:p>
-            <a:pPr algn="ctr"/>
-            <a:r>
-              <a:rPr sz="1600" b="0" i="0">
-                <a:solidFill>
-                  <a:srgbClr val="A8BBCC"/>
-                </a:solidFill>
-              </a:rPr>
-              <a:t>Gemini</a:t>
-            </a:r>
-          </a:p>
-        </p:txBody>
-      </p:sp>
-      <p:sp>
-        <p:nvSpPr>
-          <p:cNvPr id="29" name="TextBox 28"/>
-          <p:cNvSpPr txBox="1"/>
-          <p:nvPr/>
-        </p:nvSpPr>
-        <p:spPr>
-          <a:xfrm>
-            <a:off x="4846320" y="6327648"/>
-            <a:ext cx="2743200" cy="365760"/>
-          </a:xfrm>
-          <a:prstGeom prst="rect">
-            <a:avLst/>
-          </a:prstGeom>
-          <a:noFill/>
-        </p:spPr>
-        <p:txBody>
-          <a:bodyPr wrap="square">
-            <a:spAutoFit/>
-          </a:bodyPr>
-          <a:lstStyle/>
-          <a:p>
-            <a:pPr algn="ctr"/>
-            <a:r>
-              <a:rPr sz="2000" b="1" i="0">
-                <a:solidFill>
-                  <a:srgbClr val="FF4D4D"/>
-                </a:solidFill>
-              </a:rPr>
-              <a:t>✗</a:t>
-            </a:r>
-          </a:p>
-        </p:txBody>
-      </p:sp>
-      <p:sp>
-        <p:nvSpPr>
-          <p:cNvPr id="30" name="TextBox 29"/>
-          <p:cNvSpPr txBox="1"/>
-          <p:nvPr/>
-        </p:nvSpPr>
-        <p:spPr>
-          <a:xfrm>
-            <a:off x="8321040" y="5943600"/>
-            <a:ext cx="2743200" cy="411480"/>
-          </a:xfrm>
-          <a:prstGeom prst="rect">
-            <a:avLst/>
-          </a:prstGeom>
-          <a:noFill/>
-        </p:spPr>
-        <p:txBody>
-          <a:bodyPr wrap="square">
-            <a:spAutoFit/>
-          </a:bodyPr>
-          <a:lstStyle/>
-          <a:p>
-            <a:pPr algn="ctr"/>
-            <a:r>
-              <a:rPr sz="1600" b="0" i="0">
-                <a:solidFill>
-                  <a:srgbClr val="A8BBCC"/>
-                </a:solidFill>
-              </a:rPr>
-              <a:t>AgentRun</a:t>
-            </a:r>
-          </a:p>
-        </p:txBody>
-      </p:sp>
-      <p:sp>
-        <p:nvSpPr>
-          <p:cNvPr id="31" name="TextBox 30"/>
-          <p:cNvSpPr txBox="1"/>
-          <p:nvPr/>
-        </p:nvSpPr>
-        <p:spPr>
-          <a:xfrm>
-            <a:off x="8321040" y="6327648"/>
-            <a:ext cx="2743200" cy="365760"/>
-          </a:xfrm>
-          <a:prstGeom prst="rect">
-            <a:avLst/>
-          </a:prstGeom>
-          <a:noFill/>
-        </p:spPr>
-        <p:txBody>
-          <a:bodyPr wrap="square">
-            <a:spAutoFit/>
-          </a:bodyPr>
-          <a:lstStyle/>
-          <a:p>
-            <a:pPr algn="ctr"/>
-            <a:r>
-              <a:rPr sz="2000" b="1" i="0">
-                <a:solidFill>
-                  <a:srgbClr val="00C86E"/>
-                </a:solidFill>
-              </a:rPr>
-              <a:t>✅</a:t>
-            </a:r>
-          </a:p>
-        </p:txBody>
-      </p:sp>
-      <p:sp>
-        <p:nvSpPr>
-          <p:cNvPr id="32" name="TextBox 31"/>
-          <p:cNvSpPr txBox="1"/>
-          <p:nvPr/>
-        </p:nvSpPr>
-        <p:spPr>
-          <a:xfrm>
-            <a:off x="457200" y="6446520"/>
-            <a:ext cx="10972800" cy="320040"/>
-          </a:xfrm>
-          <a:prstGeom prst="rect">
-            <a:avLst/>
-          </a:prstGeom>
-          <a:noFill/>
-        </p:spPr>
-        <p:txBody>
-          <a:bodyPr wrap="square">
-            <a:spAutoFit/>
-          </a:bodyPr>
-          <a:lstStyle/>
-          <a:p>
-            <a:pPr algn="ctr"/>
-            <a:r>
-              <a:rPr sz="1300" b="0" i="1">
-                <a:solidFill>
-                  <a:srgbClr val="5A7A94"/>
-                </a:solidFill>
-              </a:rPr>
-              <a:t>护城河：RC Phone API  —  竞争对手没有</a:t>
+              <a:rPr sz="1300" b="1" i="0">
+                <a:solidFill>
+                  <a:srgbClr val="00D4BE"/>
+                </a:solidFill>
+              </a:rPr>
+              <a:t>护城河：RC Team Message + SMS API  —  一张 Card 就能完成跨部门信息传递</a:t>
             </a:r>
           </a:p>
         </p:txBody>

</xml_diff>